<commit_message>
Ruling 42: an arrow is not an equals sign — every arrow on a student page in Units 3 and 4 replaced by what it meant; rebuilt on kit 83cf462
Co-Authored-By: Claude Opus 5.5 <noreply@anthropic.com>
Claude-Session: https://claude.ai/code/session_015xYWeLUsuszQH6z7ADE9tj
</commit_message>
<xml_diff>
--- a/a7/build/out/u3/A7 3.08 Writing Large Numbers in Scientific Notation - Slides.pptx
+++ b/a7/build/out/u3/A7 3.08 Writing Large Numbers in Scientific Notation - Slides.pptx
@@ -17257,25 +17257,7 @@
                 </a:solidFill>
                 <a:latin typeface="Lexend"/>
               </a:rPr>
-              <a:t>The exponent is how many places the decimal point moves: 26,000,000. </a:t>
-            </a:r>
-            <a:r>
-              <a:rPr sz="2180" b="0" i="0">
-                <a:solidFill>
-                  <a:srgbClr val="1A1A1A"/>
-                </a:solidFill>
-                <a:latin typeface="Arial"/>
-              </a:rPr>
-              <a:t>→</a:t>
-            </a:r>
-            <a:r>
-              <a:rPr sz="2180" b="0" i="0">
-                <a:solidFill>
-                  <a:srgbClr val="1A1A1A"/>
-                </a:solidFill>
-                <a:latin typeface="Lexend"/>
-              </a:rPr>
-              <a:t> 2.6, seven places, so 10</a:t>
+              <a:t>The exponent is how many places the decimal point moves: from 26,000,000. to 2.6 is seven places, so 10</a:t>
             </a:r>
             <a:r>
               <a:rPr sz="2180" b="0" i="0" baseline="30000">

</xml_diff>